<commit_message>
Präsentationen: Link zur Kursseite (TaskCard) präzisiert
Co-Authored-By: Claude Opus 5.5 <noreply@anthropic.com>
Claude-Session: https://claude.ai/code/session_01KjTLRV2ju5iuSRgoeZgmvB
</commit_message>
<xml_diff>
--- a/technikdidaktisches-kolloquium/praesentationen/TdK_Termin-1_Technik-und-Technikunterricht.pptx
+++ b/technikdidaktisches-kolloquium/praesentationen/TdK_Termin-1_Technik-und-Technikunterricht.pptx
@@ -1222,7 +1222,7 @@
           <a:p>
             <a:r>
               <a:rPr lang="en-US" dirty="0"/>
-              <a:t>Link und QR-Code zur Lernplattform: https://t1p.de/tdk-26</a:t>
+              <a:t>Link und QR-Code zur Kursseite (TaskCard): https://t1p.de/tdk-26. Dort in der Spalte Aufgaben der Link zur Lernplattform.</a:t>
             </a:r>
             <a:endParaRPr lang="en-US" dirty="0"/>
           </a:p>
@@ -13174,7 +13174,7 @@
                   <a:srgbClr val="14232F"/>
                 </a:solidFill>
               </a:rPr>
-              <a:t>Lernplattform: </a:t>
+              <a:t>Kursseite: </a:t>
             </a:r>
             <a:pPr indent="0" marL="0">
               <a:buNone/>
@@ -13232,7 +13232,7 @@
                   <a:srgbClr val="14232F"/>
                 </a:solidFill>
               </a:rPr>
-              <a:t>Termin 1 → „Nach dem Termin“</a:t>
+              <a:t>Kursseite → Lernplattform → Termin 1 → „Nach dem Termin“</a:t>
             </a:r>
             <a:endParaRPr lang="en-US" sz="2000" dirty="0"/>
           </a:p>
@@ -13258,7 +13258,7 @@
       </p:sp>
       <p:pic>
         <p:nvPicPr>
-          <p:cNvPr id="7" name="qr-113" descr="QR-Code zur Lernplattform: https://t1p.de/tdk-26">    </p:cNvPr>
+          <p:cNvPr id="7" name="qr-113" descr="QR-Code zur Kursseite: https://t1p.de/tdk-26">    </p:cNvPr>
           <p:cNvPicPr>
             <a:picLocks noChangeAspect="1"/>
           </p:cNvPicPr>
@@ -13380,7 +13380,7 @@
                   <a:srgbClr val="14232F"/>
                 </a:solidFill>
               </a:rPr>
-              <a:t>Zur Lernplattform</a:t>
+              <a:t>Kursseite und Lernplattform</a:t>
             </a:r>
             <a:endParaRPr lang="en-US" sz="2800" dirty="0"/>
           </a:p>
@@ -13416,7 +13416,7 @@
                   <a:srgbClr val="14232F"/>
                 </a:solidFill>
               </a:rPr>
-              <a:t>Lernplattform mit allen Aufgaben, Folien und Materialien</a:t>
+              <a:t>Kursseite mit Präsentationen, Material und Link zur Lernplattform</a:t>
             </a:r>
             <a:endParaRPr lang="en-US" sz="2200" dirty="0"/>
           </a:p>
@@ -13499,7 +13499,7 @@
                   <a:srgbClr val="14232F"/>
                 </a:solidFill>
               </a:rPr>
-              <a:t>Termin wählen → „Nach dem Termin“: Aufgabenpaket</a:t>
+              <a:t>Spalte „Aufgaben“ → Lernplattform</a:t>
             </a:r>
             <a:endParaRPr lang="en-US" sz="2000" dirty="0"/>
           </a:p>
@@ -13517,7 +13517,7 @@
                   <a:srgbClr val="14232F"/>
                 </a:solidFill>
               </a:rPr>
-              <a:t>Antworten werden im Browser gespeichert</a:t>
+              <a:t>Termin wählen → „Nach dem Termin“: Aufgabenpaket</a:t>
             </a:r>
             <a:endParaRPr lang="en-US" sz="2000" dirty="0"/>
           </a:p>
@@ -13543,7 +13543,7 @@
       </p:sp>
       <p:pic>
         <p:nvPicPr>
-          <p:cNvPr id="6" name="qr-118" descr="QR-Code zur Lernplattform: https://t1p.de/tdk-26">    </p:cNvPr>
+          <p:cNvPr id="6" name="qr-118" descr="QR-Code zur Kursseite: https://t1p.de/tdk-26">    </p:cNvPr>
           <p:cNvPicPr>
             <a:picLocks noChangeAspect="1"/>
           </p:cNvPicPr>

</xml_diff>